<commit_message>
Stop PowerPoint breaking words in the middle
Several bullets that needed two lines were splitting a word across the break -
"the shape c / hoice", "train is stil / l lost", "took so / me current". Simon's
master sets latinLnBrk="1" on its body style, which permits a break at any
character rather than at word boundaries, and every bullet inherits it.

The attribute reads the opposite way round to its name: "1" allows the break.
Turning it off per paragraph restores ordinary word wrapping.

Co-Authored-By: Claude Opus 5 (1M context) <noreply@anthropic.com>
</commit_message>
<xml_diff>
--- a/results/meeting_deck_2026-09-24/0924_track1_story.pptx
+++ b/results/meeting_deck_2026-09-24/0924_track1_story.pptx
@@ -4331,7 +4331,7 @@
           <a:bodyPr/>
           <a:lstStyle/>
           <a:p>
-            <a:pPr>
+            <a:pPr latinLnBrk="0">
               <a:spcAft>
                 <a:spcPts val="400"/>
               </a:spcAft>
@@ -4342,14 +4342,14 @@
             </a:r>
           </a:p>
           <a:p>
-            <a:pPr>
+            <a:pPr latinLnBrk="0">
               <a:spcAft>
                 <a:spcPts val="400"/>
               </a:spcAft>
             </a:pPr>
           </a:p>
           <a:p>
-            <a:pPr>
+            <a:pPr latinLnBrk="0">
               <a:spcAft>
                 <a:spcPts val="400"/>
               </a:spcAft>
@@ -4360,14 +4360,14 @@
             </a:r>
           </a:p>
           <a:p>
-            <a:pPr>
+            <a:pPr latinLnBrk="0">
               <a:spcAft>
                 <a:spcPts val="400"/>
               </a:spcAft>
             </a:pPr>
           </a:p>
           <a:p>
-            <a:pPr>
+            <a:pPr latinLnBrk="0">
               <a:spcAft>
                 <a:spcPts val="400"/>
               </a:spcAft>
@@ -4378,7 +4378,7 @@
             </a:r>
           </a:p>
           <a:p>
-            <a:pPr>
+            <a:pPr latinLnBrk="0">
               <a:spcAft>
                 <a:spcPts val="400"/>
               </a:spcAft>
@@ -4453,7 +4453,7 @@
           <a:bodyPr/>
           <a:lstStyle/>
           <a:p>
-            <a:pPr>
+            <a:pPr latinLnBrk="0">
               <a:spcAft>
                 <a:spcPts val="400"/>
               </a:spcAft>
@@ -4464,7 +4464,7 @@
             </a:r>
           </a:p>
           <a:p>
-            <a:pPr>
+            <a:pPr latinLnBrk="0">
               <a:spcAft>
                 <a:spcPts val="400"/>
               </a:spcAft>
@@ -4479,7 +4479,7 @@
             </a:r>
           </a:p>
           <a:p>
-            <a:pPr>
+            <a:pPr latinLnBrk="0">
               <a:spcAft>
                 <a:spcPts val="400"/>
               </a:spcAft>
@@ -4490,7 +4490,7 @@
             </a:r>
           </a:p>
           <a:p>
-            <a:pPr>
+            <a:pPr latinLnBrk="0">
               <a:spcAft>
                 <a:spcPts val="400"/>
               </a:spcAft>
@@ -4589,7 +4589,7 @@
           <a:bodyPr/>
           <a:lstStyle/>
           <a:p>
-            <a:pPr>
+            <a:pPr latinLnBrk="0">
               <a:spcAft>
                 <a:spcPts val="400"/>
               </a:spcAft>
@@ -4608,7 +4608,7 @@
             </a:r>
           </a:p>
           <a:p>
-            <a:pPr>
+            <a:pPr latinLnBrk="0">
               <a:spcAft>
                 <a:spcPts val="400"/>
               </a:spcAft>
@@ -4619,7 +4619,7 @@
             </a:r>
           </a:p>
           <a:p>
-            <a:pPr>
+            <a:pPr latinLnBrk="0">
               <a:spcAft>
                 <a:spcPts val="400"/>
               </a:spcAft>
@@ -4718,7 +4718,7 @@
           <a:bodyPr/>
           <a:lstStyle/>
           <a:p>
-            <a:pPr>
+            <a:pPr latinLnBrk="0">
               <a:spcAft>
                 <a:spcPts val="400"/>
               </a:spcAft>
@@ -4729,7 +4729,7 @@
             </a:r>
           </a:p>
           <a:p>
-            <a:pPr>
+            <a:pPr latinLnBrk="0">
               <a:spcAft>
                 <a:spcPts val="400"/>
               </a:spcAft>
@@ -4748,7 +4748,7 @@
             </a:r>
           </a:p>
           <a:p>
-            <a:pPr>
+            <a:pPr latinLnBrk="0">
               <a:spcAft>
                 <a:spcPts val="400"/>
               </a:spcAft>
@@ -4847,7 +4847,7 @@
           <a:bodyPr/>
           <a:lstStyle/>
           <a:p>
-            <a:pPr>
+            <a:pPr latinLnBrk="0">
               <a:spcAft>
                 <a:spcPts val="400"/>
               </a:spcAft>
@@ -4866,7 +4866,7 @@
             </a:r>
           </a:p>
           <a:p>
-            <a:pPr>
+            <a:pPr latinLnBrk="0">
               <a:spcAft>
                 <a:spcPts val="400"/>
               </a:spcAft>
@@ -4969,7 +4969,7 @@
           <a:bodyPr/>
           <a:lstStyle/>
           <a:p>
-            <a:pPr>
+            <a:pPr latinLnBrk="0">
               <a:spcAft>
                 <a:spcPts val="400"/>
               </a:spcAft>
@@ -4980,7 +4980,7 @@
             </a:r>
           </a:p>
           <a:p>
-            <a:pPr>
+            <a:pPr latinLnBrk="0">
               <a:spcAft>
                 <a:spcPts val="400"/>
               </a:spcAft>
@@ -5079,7 +5079,7 @@
           <a:bodyPr/>
           <a:lstStyle/>
           <a:p>
-            <a:pPr>
+            <a:pPr latinLnBrk="0">
               <a:spcAft>
                 <a:spcPts val="400"/>
               </a:spcAft>
@@ -5090,7 +5090,7 @@
             </a:r>
           </a:p>
           <a:p>
-            <a:pPr>
+            <a:pPr latinLnBrk="0">
               <a:spcAft>
                 <a:spcPts val="400"/>
               </a:spcAft>
@@ -5189,7 +5189,7 @@
           <a:bodyPr/>
           <a:lstStyle/>
           <a:p>
-            <a:pPr>
+            <a:pPr latinLnBrk="0">
               <a:spcAft>
                 <a:spcPts val="400"/>
               </a:spcAft>
@@ -5208,7 +5208,7 @@
             </a:r>
           </a:p>
           <a:p>
-            <a:pPr>
+            <a:pPr latinLnBrk="0">
               <a:spcAft>
                 <a:spcPts val="400"/>
               </a:spcAft>
@@ -5227,7 +5227,7 @@
             </a:r>
           </a:p>
           <a:p>
-            <a:pPr>
+            <a:pPr latinLnBrk="0">
               <a:spcAft>
                 <a:spcPts val="400"/>
               </a:spcAft>
@@ -5326,7 +5326,7 @@
           <a:bodyPr/>
           <a:lstStyle/>
           <a:p>
-            <a:pPr>
+            <a:pPr latinLnBrk="0">
               <a:spcAft>
                 <a:spcPts val="400"/>
               </a:spcAft>
@@ -5337,7 +5337,7 @@
             </a:r>
           </a:p>
           <a:p>
-            <a:pPr>
+            <a:pPr latinLnBrk="0">
               <a:spcAft>
                 <a:spcPts val="400"/>
               </a:spcAft>
@@ -5352,7 +5352,7 @@
             </a:r>
           </a:p>
           <a:p>
-            <a:pPr>
+            <a:pPr latinLnBrk="0">
               <a:spcAft>
                 <a:spcPts val="400"/>
               </a:spcAft>
@@ -5447,7 +5447,7 @@
           <a:bodyPr/>
           <a:lstStyle/>
           <a:p>
-            <a:pPr>
+            <a:pPr latinLnBrk="0">
               <a:spcAft>
                 <a:spcPts val="400"/>
               </a:spcAft>
@@ -5466,7 +5466,7 @@
             </a:r>
           </a:p>
           <a:p>
-            <a:pPr>
+            <a:pPr latinLnBrk="0">
               <a:spcAft>
                 <a:spcPts val="400"/>
               </a:spcAft>
@@ -5477,7 +5477,7 @@
             </a:r>
           </a:p>
           <a:p>
-            <a:pPr>
+            <a:pPr latinLnBrk="0">
               <a:spcAft>
                 <a:spcPts val="400"/>
               </a:spcAft>
@@ -5576,7 +5576,7 @@
           <a:bodyPr/>
           <a:lstStyle/>
           <a:p>
-            <a:pPr>
+            <a:pPr latinLnBrk="0">
               <a:spcAft>
                 <a:spcPts val="400"/>
               </a:spcAft>
@@ -5595,7 +5595,7 @@
             </a:r>
           </a:p>
           <a:p>
-            <a:pPr>
+            <a:pPr latinLnBrk="0">
               <a:spcAft>
                 <a:spcPts val="400"/>
               </a:spcAft>
@@ -5614,7 +5614,7 @@
             </a:r>
           </a:p>
           <a:p>
-            <a:pPr>
+            <a:pPr latinLnBrk="0">
               <a:spcAft>
                 <a:spcPts val="400"/>
               </a:spcAft>
@@ -5717,7 +5717,7 @@
           <a:bodyPr/>
           <a:lstStyle/>
           <a:p>
-            <a:pPr>
+            <a:pPr latinLnBrk="0">
               <a:spcAft>
                 <a:spcPts val="400"/>
               </a:spcAft>
@@ -5728,7 +5728,7 @@
             </a:r>
           </a:p>
           <a:p>
-            <a:pPr>
+            <a:pPr latinLnBrk="0">
               <a:spcAft>
                 <a:spcPts val="400"/>
               </a:spcAft>
@@ -5831,7 +5831,7 @@
           <a:bodyPr/>
           <a:lstStyle/>
           <a:p>
-            <a:pPr>
+            <a:pPr latinLnBrk="0">
               <a:spcAft>
                 <a:spcPts val="400"/>
               </a:spcAft>
@@ -5850,7 +5850,7 @@
             </a:r>
           </a:p>
           <a:p>
-            <a:pPr>
+            <a:pPr latinLnBrk="0">
               <a:spcAft>
                 <a:spcPts val="400"/>
               </a:spcAft>
@@ -5861,7 +5861,7 @@
             </a:r>
           </a:p>
           <a:p>
-            <a:pPr>
+            <a:pPr latinLnBrk="0">
               <a:spcAft>
                 <a:spcPts val="400"/>
               </a:spcAft>
@@ -5960,7 +5960,7 @@
           <a:bodyPr/>
           <a:lstStyle/>
           <a:p>
-            <a:pPr>
+            <a:pPr latinLnBrk="0">
               <a:spcAft>
                 <a:spcPts val="400"/>
               </a:spcAft>
@@ -5979,7 +5979,7 @@
             </a:r>
           </a:p>
           <a:p>
-            <a:pPr>
+            <a:pPr latinLnBrk="0">
               <a:spcAft>
                 <a:spcPts val="400"/>
               </a:spcAft>
@@ -5998,7 +5998,7 @@
             </a:r>
           </a:p>
           <a:p>
-            <a:pPr>
+            <a:pPr latinLnBrk="0">
               <a:spcAft>
                 <a:spcPts val="400"/>
               </a:spcAft>
@@ -6097,7 +6097,7 @@
           <a:bodyPr/>
           <a:lstStyle/>
           <a:p>
-            <a:pPr>
+            <a:pPr latinLnBrk="0">
               <a:spcAft>
                 <a:spcPts val="400"/>
               </a:spcAft>
@@ -6112,7 +6112,7 @@
             </a:r>
           </a:p>
           <a:p>
-            <a:pPr>
+            <a:pPr latinLnBrk="0">
               <a:spcAft>
                 <a:spcPts val="400"/>
               </a:spcAft>
@@ -6127,7 +6127,7 @@
             </a:r>
           </a:p>
           <a:p>
-            <a:pPr>
+            <a:pPr latinLnBrk="0">
               <a:spcAft>
                 <a:spcPts val="400"/>
               </a:spcAft>
@@ -6142,7 +6142,7 @@
             </a:r>
           </a:p>
           <a:p>
-            <a:pPr>
+            <a:pPr latinLnBrk="0">
               <a:spcAft>
                 <a:spcPts val="400"/>
               </a:spcAft>
@@ -6245,7 +6245,7 @@
           <a:bodyPr/>
           <a:lstStyle/>
           <a:p>
-            <a:pPr>
+            <a:pPr latinLnBrk="0">
               <a:spcAft>
                 <a:spcPts val="400"/>
               </a:spcAft>
@@ -6256,7 +6256,7 @@
             </a:r>
           </a:p>
           <a:p>
-            <a:pPr>
+            <a:pPr latinLnBrk="0">
               <a:spcAft>
                 <a:spcPts val="400"/>
               </a:spcAft>
@@ -6267,7 +6267,7 @@
             </a:r>
           </a:p>
           <a:p>
-            <a:pPr>
+            <a:pPr latinLnBrk="0">
               <a:spcAft>
                 <a:spcPts val="400"/>
               </a:spcAft>
@@ -6370,7 +6370,7 @@
           <a:bodyPr/>
           <a:lstStyle/>
           <a:p>
-            <a:pPr>
+            <a:pPr latinLnBrk="0">
               <a:spcAft>
                 <a:spcPts val="400"/>
               </a:spcAft>
@@ -6385,7 +6385,7 @@
             </a:r>
           </a:p>
           <a:p>
-            <a:pPr>
+            <a:pPr latinLnBrk="0">
               <a:spcAft>
                 <a:spcPts val="400"/>
               </a:spcAft>
@@ -6400,7 +6400,7 @@
             </a:r>
           </a:p>
           <a:p>
-            <a:pPr>
+            <a:pPr latinLnBrk="0">
               <a:spcAft>
                 <a:spcPts val="400"/>
               </a:spcAft>
@@ -6415,7 +6415,7 @@
             </a:r>
           </a:p>
           <a:p>
-            <a:pPr>
+            <a:pPr latinLnBrk="0">
               <a:spcAft>
                 <a:spcPts val="400"/>
               </a:spcAft>
@@ -6518,7 +6518,7 @@
           <a:bodyPr/>
           <a:lstStyle/>
           <a:p>
-            <a:pPr>
+            <a:pPr latinLnBrk="0">
               <a:spcAft>
                 <a:spcPts val="400"/>
               </a:spcAft>
@@ -6537,7 +6537,7 @@
             </a:r>
           </a:p>
           <a:p>
-            <a:pPr>
+            <a:pPr latinLnBrk="0">
               <a:spcAft>
                 <a:spcPts val="400"/>
               </a:spcAft>
@@ -6632,7 +6632,7 @@
           <a:bodyPr/>
           <a:lstStyle/>
           <a:p>
-            <a:pPr>
+            <a:pPr latinLnBrk="0">
               <a:spcAft>
                 <a:spcPts val="400"/>
               </a:spcAft>
@@ -6643,7 +6643,7 @@
             </a:r>
           </a:p>
           <a:p>
-            <a:pPr>
+            <a:pPr latinLnBrk="0">
               <a:spcAft>
                 <a:spcPts val="400"/>
               </a:spcAft>
@@ -6742,7 +6742,7 @@
           <a:bodyPr/>
           <a:lstStyle/>
           <a:p>
-            <a:pPr>
+            <a:pPr latinLnBrk="0">
               <a:spcAft>
                 <a:spcPts val="400"/>
               </a:spcAft>
@@ -6753,7 +6753,7 @@
             </a:r>
           </a:p>
           <a:p>
-            <a:pPr>
+            <a:pPr latinLnBrk="0">
               <a:spcAft>
                 <a:spcPts val="400"/>
               </a:spcAft>
@@ -6764,7 +6764,7 @@
             </a:r>
           </a:p>
           <a:p>
-            <a:pPr>
+            <a:pPr latinLnBrk="0">
               <a:spcAft>
                 <a:spcPts val="400"/>
               </a:spcAft>
@@ -6867,7 +6867,7 @@
           <a:bodyPr/>
           <a:lstStyle/>
           <a:p>
-            <a:pPr>
+            <a:pPr latinLnBrk="0">
               <a:spcAft>
                 <a:spcPts val="400"/>
               </a:spcAft>
@@ -6878,7 +6878,7 @@
             </a:r>
           </a:p>
           <a:p>
-            <a:pPr>
+            <a:pPr latinLnBrk="0">
               <a:spcAft>
                 <a:spcPts val="400"/>
               </a:spcAft>
@@ -6981,7 +6981,7 @@
           <a:bodyPr/>
           <a:lstStyle/>
           <a:p>
-            <a:pPr>
+            <a:pPr latinLnBrk="0">
               <a:spcAft>
                 <a:spcPts val="400"/>
               </a:spcAft>
@@ -6992,7 +6992,7 @@
             </a:r>
           </a:p>
           <a:p>
-            <a:pPr>
+            <a:pPr latinLnBrk="0">
               <a:spcAft>
                 <a:spcPts val="400"/>
               </a:spcAft>
@@ -7091,7 +7091,7 @@
           <a:bodyPr/>
           <a:lstStyle/>
           <a:p>
-            <a:pPr>
+            <a:pPr latinLnBrk="0">
               <a:spcAft>
                 <a:spcPts val="400"/>
               </a:spcAft>
@@ -7102,7 +7102,7 @@
             </a:r>
           </a:p>
           <a:p>
-            <a:pPr>
+            <a:pPr latinLnBrk="0">
               <a:spcAft>
                 <a:spcPts val="400"/>
               </a:spcAft>
@@ -7201,7 +7201,7 @@
           <a:bodyPr/>
           <a:lstStyle/>
           <a:p>
-            <a:pPr>
+            <a:pPr latinLnBrk="0">
               <a:spcAft>
                 <a:spcPts val="400"/>
               </a:spcAft>
@@ -7212,7 +7212,7 @@
             </a:r>
           </a:p>
           <a:p>
-            <a:pPr>
+            <a:pPr latinLnBrk="0">
               <a:spcAft>
                 <a:spcPts val="400"/>
               </a:spcAft>
@@ -7223,7 +7223,7 @@
             </a:r>
           </a:p>
           <a:p>
-            <a:pPr>
+            <a:pPr latinLnBrk="0">
               <a:spcAft>
                 <a:spcPts val="400"/>
               </a:spcAft>
@@ -7322,7 +7322,7 @@
           <a:bodyPr/>
           <a:lstStyle/>
           <a:p>
-            <a:pPr>
+            <a:pPr latinLnBrk="0">
               <a:spcAft>
                 <a:spcPts val="400"/>
               </a:spcAft>
@@ -7333,7 +7333,7 @@
             </a:r>
           </a:p>
           <a:p>
-            <a:pPr>
+            <a:pPr latinLnBrk="0">
               <a:spcAft>
                 <a:spcPts val="400"/>
               </a:spcAft>
@@ -7344,7 +7344,7 @@
             </a:r>
           </a:p>
           <a:p>
-            <a:pPr>
+            <a:pPr latinLnBrk="0">
               <a:spcAft>
                 <a:spcPts val="400"/>
               </a:spcAft>
@@ -7443,7 +7443,7 @@
           <a:bodyPr/>
           <a:lstStyle/>
           <a:p>
-            <a:pPr>
+            <a:pPr latinLnBrk="0">
               <a:spcAft>
                 <a:spcPts val="400"/>
               </a:spcAft>
@@ -7454,7 +7454,7 @@
             </a:r>
           </a:p>
           <a:p>
-            <a:pPr>
+            <a:pPr latinLnBrk="0">
               <a:spcAft>
                 <a:spcPts val="400"/>
               </a:spcAft>
@@ -7553,7 +7553,7 @@
           <a:bodyPr/>
           <a:lstStyle/>
           <a:p>
-            <a:pPr>
+            <a:pPr latinLnBrk="0">
               <a:spcAft>
                 <a:spcPts val="400"/>
               </a:spcAft>
@@ -7572,7 +7572,7 @@
             </a:r>
           </a:p>
           <a:p>
-            <a:pPr>
+            <a:pPr latinLnBrk="0">
               <a:spcAft>
                 <a:spcPts val="400"/>
               </a:spcAft>
@@ -7583,14 +7583,14 @@
             </a:r>
           </a:p>
           <a:p>
-            <a:pPr>
+            <a:pPr latinLnBrk="0">
               <a:spcAft>
                 <a:spcPts val="400"/>
               </a:spcAft>
             </a:pPr>
           </a:p>
           <a:p>
-            <a:pPr>
+            <a:pPr latinLnBrk="0">
               <a:spcAft>
                 <a:spcPts val="400"/>
               </a:spcAft>
@@ -7605,14 +7605,14 @@
             </a:r>
           </a:p>
           <a:p>
-            <a:pPr>
+            <a:pPr latinLnBrk="0">
               <a:spcAft>
                 <a:spcPts val="400"/>
               </a:spcAft>
             </a:pPr>
           </a:p>
           <a:p>
-            <a:pPr>
+            <a:pPr latinLnBrk="0">
               <a:spcAft>
                 <a:spcPts val="400"/>
               </a:spcAft>

</xml_diff>